<commit_message>
Update documentation and diagrams for clarity and accuracy
- Revised README to clarify the trigger conditions for local authority declarations.
- Enhanced deck documentation with detailed descriptions of emergency mode and system interactions.
- Updated concept documentation to reflect changes in the trust model and key generation process.
- Improved prior art section with additional context on community networks.
- Adjusted non-functional requirements to specify key management and privacy measures.
- Refined diagrams to better illustrate system architecture and trust model.

These changes aim to improve understanding and usability of the documentation for developers and stakeholders.
</commit_message>
<xml_diff>
--- a/docs/pitch/pomoc.pptx
+++ b/docs/pitch/pomoc.pptx
@@ -11,11 +11,11 @@
     <p:sldId id="256" r:id="rId3"/>
     <p:sldId id="257" r:id="rId4"/>
     <p:sldId id="258" r:id="rId5"/>
+    <p:sldId id="263" r:id="rId10"/>
+    <p:sldId id="262" r:id="rId9"/>
+    <p:sldId id="261" r:id="rId8"/>
     <p:sldId id="259" r:id="rId6"/>
     <p:sldId id="260" r:id="rId7"/>
-    <p:sldId id="261" r:id="rId8"/>
-    <p:sldId id="262" r:id="rId9"/>
-    <p:sldId id="263" r:id="rId10"/>
     <p:sldId id="264" r:id="rId11"/>
     <p:sldId id="265" r:id="rId12"/>
   </p:sldIdLst>
@@ -2600,7 +2600,7 @@
                 <a:ea typeface="Calibri"/>
                 <a:cs typeface="Calibri"/>
               </a:rPr>
-              <a:t>TR-369 router management, BLE / Wi-Fi Aware, PKI with secure-element keys</a:t>
+              <a:t>802.11s router mesh (Freifunk-proven), BLE / Wi-Fi Aware, TR-369, PKI with secure-element keys</a:t>
             </a:r>
             <a:endParaRPr lang="en-US" sz="1500"/>
           </a:p>
@@ -2753,7 +2753,7 @@
                 <a:ea typeface="Calibri"/>
                 <a:cs typeface="Calibri"/>
               </a:rPr>
-              <a:t>Life-critical requests, casualty reports with position, and verified official alerts keep moving without cells or power.</a:t>
+              <a:t>Life-critical requests, casualty reports with voluntarily shared position, and verified official alerts keep moving without cells or power.</a:t>
             </a:r>
             <a:endParaRPr lang="en-US" sz="1300"/>
           </a:p>
@@ -2874,7 +2874,7 @@
                 <a:ea typeface="Calibri"/>
                 <a:cs typeface="Calibri"/>
               </a:rPr>
-              <a:t>Concept, research, docs, simulation and this deck were made with AI assistance (Claude Code); the team stands behind all of it.</a:t>
+              <a:t>Concept, research, docs, simulation and this deck were made with AI assistance (Claude Code; title illustration generated with Gemini); the team stands behind all of it.</a:t>
             </a:r>
             <a:endParaRPr lang="en-US" sz="1300"/>
           </a:p>
@@ -4057,7 +4057,7 @@
                 <a:ea typeface="Calibri"/>
                 <a:cs typeface="Calibri"/>
               </a:rPr>
-              <a:t>No backbone needed: phones and home routers relay hop by hop</a:t>
+              <a:t>No operator network needed: home routers mesh over Wi-Fi, phones relay over Bluetooth LE</a:t>
             </a:r>
             <a:endParaRPr lang="en-US" sz="1500"/>
           </a:p>
@@ -4146,7 +4146,7 @@
                 <a:ea typeface="Cambria"/>
                 <a:cs typeface="Cambria"/>
               </a:rPr>
-              <a:t>Runs on what the city already has: phones and ISP routers. Routers are the static backbone, phones the mobile edge.</a:t>
+              <a:t>Runs on what the city already has: phones and ISP routers. Routers are the Wi-Fi mesh backbone, phones the Bluetooth edge.</a:t>
             </a:r>
             <a:endParaRPr lang="en-US" sz="1900"/>
           </a:p>
@@ -4371,7 +4371,7 @@
             </a:pPr>
             <a:fld id="{F7021451-1387-4CA6-816F-3879F97B5CBC}" type="slidenum">
               <a:rPr lang="en-US" b="0"/>
-              <a:t>4</a:t>
+              <a:t>7</a:t>
             </a:fld>
             <a:endParaRPr lang="en-US"/>
           </a:p>
@@ -4560,7 +4560,7 @@
                 <a:ea typeface="Calibri"/>
                 <a:cs typeface="Calibri"/>
               </a:rPr>
-              <a:t>through the national identity wallet (mObywatel / EUDI). The Authority issues a key and a citizen certificate, delivered wrapped into the phone's secure element.</a:t>
+              <a:t>through the national identity wallet (mObywatel / EUDI). The key is born in the phone's secure chip and never leaves it; the Authority verifies the person and the device, then signs a citizen certificate.</a:t>
             </a:r>
             <a:endParaRPr lang="en-US" sz="1500"/>
           </a:p>
@@ -4656,7 +4656,7 @@
                 <a:ea typeface="Calibri"/>
                 <a:cs typeface="Calibri"/>
               </a:rPr>
-              <a:t>~30-day keys, re-issued silently, through the mesh when the internet is gone.</a:t>
+              <a:t>~30-day keys: the phone makes a new one and the Authority re-signs it, through the mesh when the internet is gone.</a:t>
             </a:r>
             <a:endParaRPr lang="en-US" sz="1500"/>
           </a:p>
@@ -4688,7 +4688,7 @@
                 <a:ea typeface="Calibri"/>
                 <a:cs typeface="Calibri"/>
               </a:rPr>
-              <a:t>Declarations and alerts carry Authority signatures; anything unverifiable is dropped at the first hop.</a:t>
+              <a:t>Local authorities sign declarations for their area with keys under the Authority root; alerts are signed too. Anything unverifiable is dropped at the first hop.</a:t>
             </a:r>
             <a:endParaRPr lang="en-US" sz="1500"/>
           </a:p>
@@ -4733,7 +4733,7 @@
             </a:pPr>
             <a:fld id="{F7021451-1387-4CA6-816F-3879F97B5CBC}" type="slidenum">
               <a:rPr lang="en-US" b="0"/>
-              <a:t>5</a:t>
+              <a:t>8</a:t>
             </a:fld>
             <a:endParaRPr lang="en-US"/>
           </a:p>
@@ -4985,7 +4985,7 @@
                 <a:ea typeface="Calibri"/>
                 <a:cs typeface="Calibri"/>
               </a:rPr>
-              <a:t>Elderly check-in: </a:t>
+              <a:t>Daily OK (opt-in senior care): </a:t>
             </a:r>
             <a:r>
               <a:rPr lang="en-US" sz="1500">
@@ -4996,7 +4996,7 @@
                 <a:ea typeface="Calibri"/>
                 <a:cs typeface="Calibri"/>
               </a:rPr>
-              <a:t>no device activity for a set time → the closest hops are asked to look in on the person, who may have fallen</a:t>
+              <a:t>no phone use for hours or a detected fall → the phone asks “Are you OK?” → the people the senior chose → only then nearest neighbours and 112</a:t>
             </a:r>
             <a:endParaRPr lang="en-US" sz="1500"/>
           </a:p>
@@ -6158,7 +6158,7 @@
                           <a:ea typeface="Calibri"/>
                           <a:cs typeface="Calibri"/>
                         </a:rPr>
-                        <a:t>automatic (no backhaul) or declaration</a:t>
+                        <a:t>automatic (no backhaul) or local authority</a:t>
                       </a:r>
                       <a:endParaRPr lang="en-US" sz="1400">
                         <a:latin typeface="Calibri"/>
@@ -6207,7 +6207,7 @@
                           <a:ea typeface="Calibri"/>
                           <a:cs typeface="Calibri"/>
                         </a:rPr>
-                        <a:t>declaration only</a:t>
+                        <a:t>local authority declaration</a:t>
                       </a:r>
                       <a:endParaRPr lang="en-US" sz="1400">
                         <a:latin typeface="Calibri"/>
@@ -6256,7 +6256,7 @@
                           <a:ea typeface="Calibri"/>
                           <a:cs typeface="Calibri"/>
                         </a:rPr>
-                        <a:t>declaration only</a:t>
+                        <a:t>local authority declaration</a:t>
                       </a:r>
                       <a:endParaRPr lang="en-US" sz="1400">
                         <a:latin typeface="Calibri"/>
@@ -6658,7 +6658,7 @@
                           <a:ea typeface="Calibri"/>
                           <a:cs typeface="Calibri"/>
                         </a:rPr>
-                        <a:t>casualty reporting: position + short message to the authorities</a:t>
+                        <a:t>casualty reporting: voluntary position + short message, sealed to the authorities</a:t>
                       </a:r>
                       <a:endParaRPr lang="en-US" sz="1400">
                         <a:latin typeface="Calibri"/>
@@ -7002,7 +7002,7 @@
             </a:pPr>
             <a:fld id="{F7021451-1387-4CA6-816F-3879F97B5CBC}" type="slidenum">
               <a:rPr lang="en-US" b="0"/>
-              <a:t>7</a:t>
+              <a:t>5</a:t>
             </a:fld>
             <a:endParaRPr lang="en-US"/>
           </a:p>
@@ -7247,7 +7247,7 @@
                 <a:ea typeface="Cambria"/>
                 <a:cs typeface="Cambria"/>
               </a:rPr>
-              <a:t>Ola's phone sends a signed LIFE_CRITICAL request.</a:t>
+              <a:t>Ola sends a signed LIFE_CRITICAL request with her location attached.</a:t>
             </a:r>
             <a:endParaRPr lang="en-US" sz="1700"/>
           </a:p>
@@ -7915,7 +7915,7 @@
             </a:pPr>
             <a:fld id="{F7021451-1387-4CA6-816F-3879F97B5CBC}" type="slidenum">
               <a:rPr lang="en-US" b="0"/>
-              <a:t>8</a:t>
+              <a:t>4</a:t>
             </a:fld>
             <a:endParaRPr lang="en-US"/>
           </a:p>
@@ -8728,7 +8728,7 @@
                 <a:ea typeface="Calibri"/>
                 <a:cs typeface="Calibri"/>
               </a:rPr>
-              <a:t>L2 vs L3 side by side</a:t>
+              <a:t>L2 west, L3 east: regional declarations</a:t>
             </a:r>
             <a:endParaRPr lang="en-US" sz="1300"/>
           </a:p>
@@ -8860,7 +8860,7 @@
                 <a:ea typeface="Calibri"/>
                 <a:cs typeface="Calibri"/>
               </a:rPr>
-              <a:t>Coverage planning</a:t>
+              <a:t>Forged request rejected</a:t>
             </a:r>
             <a:endParaRPr lang="en-US" sz="1300"/>
           </a:p>
@@ -8911,7 +8911,7 @@
                 <a:ea typeface="Calibri"/>
                 <a:cs typeface="Calibri"/>
               </a:rPr>
-              <a:t>reach, delivery per class, hops, latency. Sliders for participation and radio range show the </a:t>
+              <a:t>reach, delivery per class, hops, latency. Set device counts and radio range and watch the </a:t>
             </a:r>
             <a:r>
               <a:rPr lang="en-US" sz="1400" b="1">
@@ -9107,7 +9107,7 @@
                 <a:ea typeface="Calibri"/>
                 <a:cs typeface="Calibri"/>
               </a:rPr>
-              <a:t>In progress: </a:t>
+              <a:t>Not built: </a:t>
             </a:r>
             <a:r>
               <a:rPr lang="en-US" sz="1300">
@@ -9118,7 +9118,7 @@
                 <a:ea typeface="Calibri"/>
                 <a:cs typeface="Calibri"/>
               </a:rPr>
-              <a:t>a device prototype of the protocol module</a:t>
+              <a:t>router firmware, identity integration, Authority services</a:t>
             </a:r>
             <a:endParaRPr lang="en-US" sz="1300"/>
           </a:p>
@@ -9139,7 +9139,7 @@
                 <a:ea typeface="Calibri"/>
                 <a:cs typeface="Calibri"/>
               </a:rPr>
-              <a:t>Not built: </a:t>
+              <a:t>Vision, not in the sim: </a:t>
             </a:r>
             <a:r>
               <a:rPr lang="en-US" sz="1300">
@@ -9150,7 +9150,7 @@
                 <a:ea typeface="Calibri"/>
                 <a:cs typeface="Calibri"/>
               </a:rPr>
-              <a:t>router firmware, identity integration, Authority services</a:t>
+              <a:t>coverage planning. Phone density shifts by district and over time; the city sees where Pomóc is thin and responds with relay nodes, campaigns or incentives</a:t>
             </a:r>
             <a:endParaRPr lang="en-US" sz="1300"/>
           </a:p>

</xml_diff>

<commit_message>
docs: soften overclaims and state the nonprofit funding model
Mark simulation scope honestly, label the AED scenario as vision and
state that Pomóc is government-legalised nonprofit software: ISPs are
not paid and the only cost is the gateway servers the governance
maintains anyway (FR-GOV-08, NFR-LEG-07, slide 10).
</commit_message>
<xml_diff>
--- a/docs/pitch/pomoc.pptx
+++ b/docs/pitch/pomoc.pptx
@@ -2386,7 +2386,7 @@
                 <a:ea typeface="Cambria"/>
                 <a:cs typeface="Cambria"/>
               </a:rPr>
-              <a:t>Every piece is tried and validated. Nobody has combined them.</a:t>
+              <a:t>Every piece has been tried. Nobody has combined them.</a:t>
             </a:r>
             <a:endParaRPr lang="en-US" sz="3000"/>
           </a:p>
@@ -2472,7 +2472,7 @@
                 <a:ea typeface="Calibri"/>
                 <a:cs typeface="Calibri"/>
               </a:rPr>
-              <a:t>are mandatory EU-wide: Pomóc plugs into mObywatel in Poland, DÁP in Hungary, any national wallet</a:t>
+              <a:t>are mandatory EU-wide: Pomóc would plug into mObywatel in Poland, DÁP in Hungary, any national wallet</a:t>
             </a:r>
             <a:endParaRPr lang="en-US" sz="1500"/>
           </a:p>
@@ -2536,7 +2536,7 @@
                 <a:ea typeface="Calibri"/>
                 <a:cs typeface="Calibri"/>
               </a:rPr>
-              <a:t>proved phone-to-phone message relaying after 2011</a:t>
+              <a:t>has tested phone-to-phone message relaying since 2011</a:t>
             </a:r>
             <a:endParaRPr lang="en-US" sz="1500"/>
           </a:p>
@@ -2600,7 +2600,7 @@
                 <a:ea typeface="Calibri"/>
                 <a:cs typeface="Calibri"/>
               </a:rPr>
-              <a:t>802.11s router mesh (Freifunk-proven), BLE / Wi-Fi Aware, TR-369, PKI with secure-element keys</a:t>
+              <a:t>802.11s router mesh (OpenWrt), BLE / Wi-Fi Aware, TR-369, PKI with secure-element keys</a:t>
             </a:r>
             <a:endParaRPr lang="en-US" sz="1500"/>
           </a:p>
@@ -2721,7 +2721,7 @@
                 <a:ea typeface="Calibri"/>
                 <a:cs typeface="Calibri"/>
               </a:rPr>
-              <a:t>After an attack or disaster, authorities and the military need time to respond. Pomóc keeps a communication platform alive in that gap.</a:t>
+              <a:t>After an attack or disaster, authorities and emergency services need time to respond. Pomóc keeps a communication platform alive in that gap.</a:t>
             </a:r>
             <a:endParaRPr lang="en-US" sz="1300"/>
           </a:p>
@@ -2742,7 +2742,7 @@
                 <a:ea typeface="Calibri"/>
                 <a:cs typeface="Calibri"/>
               </a:rPr>
-              <a:t>Fewer casualties. </a:t>
+              <a:t>Aim: fewer casualties. </a:t>
             </a:r>
             <a:r>
               <a:rPr lang="en-US" sz="1300">
@@ -2785,7 +2785,39 @@
                 <a:ea typeface="Calibri"/>
                 <a:cs typeface="Calibri"/>
               </a:rPr>
-              <a:t>No new hardware, no new identity scheme: phones, home routers and the national EUDI wallet.</a:t>
+              <a:t>Almost no new hardware, no new identity scheme: phones, home routers, a few battery-backed relays and the national EUDI wallet.</a:t>
+            </a:r>
+            <a:endParaRPr lang="en-US" sz="1300"/>
+          </a:p>
+          <a:p>
+            <a:pPr marL="0" indent="0">
+              <a:spcAft>
+                <a:spcPts val="800"/>
+              </a:spcAft>
+              <a:buNone/>
+              <a:defRPr/>
+            </a:pPr>
+            <a:r>
+              <a:rPr lang="en-US" sz="1300" b="1">
+                <a:solidFill>
+                  <a:srgbClr val="0E1B2C"/>
+                </a:solidFill>
+                <a:latin typeface="Calibri"/>
+                <a:ea typeface="Calibri"/>
+                <a:cs typeface="Calibri"/>
+              </a:rPr>
+              <a:t>No ISP payment. </a:t>
+            </a:r>
+            <a:r>
+              <a:rPr lang="en-US" sz="1300">
+                <a:solidFill>
+                  <a:srgbClr val="1B2A3D"/>
+                </a:solidFill>
+                <a:latin typeface="Calibri"/>
+                <a:ea typeface="Calibri"/>
+                <a:cs typeface="Calibri"/>
+              </a:rPr>
+              <a:t>Government-legalised, nonprofit software. ISPs are not paid. The only cost is the gateway servers the governance has to maintain anyway as communication hubs.</a:t>
             </a:r>
             <a:endParaRPr lang="en-US" sz="1300"/>
           </a:p>
@@ -3877,7 +3909,7 @@
                 <a:ea typeface="Calibri"/>
                 <a:cs typeface="Calibri"/>
               </a:rPr>
-              <a:t>Optional micro-payments or credits</a:t>
+              <a:t>Free by default; a fee only when a lender asks one for a loan</a:t>
             </a:r>
             <a:endParaRPr lang="en-US" sz="1500"/>
           </a:p>
@@ -4079,7 +4111,7 @@
                 <a:ea typeface="Calibri"/>
                 <a:cs typeface="Calibri"/>
               </a:rPr>
-              <a:t>Payments off, priorities on, store-and-forward on</a:t>
+              <a:t>Fees off, priorities on, store-and-forward on</a:t>
             </a:r>
             <a:endParaRPr lang="en-US" sz="1500"/>
           </a:p>
@@ -4932,7 +4964,7 @@
                 <a:ea typeface="Calibri"/>
                 <a:cs typeface="Calibri"/>
               </a:rPr>
-              <a:t>a tool pays itself back through community use</a:t>
+              <a:t>a tool lent for small fees pays itself back</a:t>
             </a:r>
             <a:endParaRPr lang="en-US" sz="1500"/>
           </a:p>
@@ -5266,7 +5298,7 @@
                 <a:ea typeface="Calibri"/>
                 <a:cs typeface="Calibri"/>
               </a:rPr>
-              <a:t>2 PLN</a:t>
+              <a:t>2 PLN fee</a:t>
             </a:r>
             <a:endParaRPr lang="en-US" sz="1200"/>
           </a:p>
@@ -6055,7 +6087,7 @@
                           <a:ea typeface="Calibri"/>
                           <a:cs typeface="Calibri"/>
                         </a:rPr>
-                        <a:t>terror, war, hybrid attack</a:t>
+                        <a:t>armed attack, hybrid threat</a:t>
                       </a:r>
                       <a:endParaRPr lang="en-US" sz="1400">
                         <a:latin typeface="Calibri"/>
@@ -6658,7 +6690,7 @@
                           <a:ea typeface="Calibri"/>
                           <a:cs typeface="Calibri"/>
                         </a:rPr>
-                        <a:t>casualty reporting: voluntary position + short message, sealed to the authorities</a:t>
+                        <a:t>life-critical, safety, “I am OK”; casualty reports sealed to the authorities</a:t>
                       </a:r>
                       <a:endParaRPr lang="en-US" sz="1400">
                         <a:latin typeface="Calibri"/>
@@ -7075,7 +7107,7 @@
                 <a:ea typeface="Calibri"/>
                 <a:cs typeface="Calibri"/>
               </a:rPr>
-              <a:t>SCENARIO</a:t>
+              <a:t>TARGET SCENARIO · VISION, NOT IN THE SIM</a:t>
             </a:r>
             <a:endParaRPr lang="en-US" sz="1100"/>
           </a:p>
@@ -7803,7 +7835,7 @@
                 <a:ea typeface="Calibri"/>
                 <a:cs typeface="Calibri"/>
               </a:rPr>
-              <a:t>One person moves, the messages did the rest. Staff would take ~6 minutes.</a:t>
+              <a:t>One person moves, the messages did the rest.</a:t>
             </a:r>
             <a:endParaRPr lang="en-US" sz="1400"/>
           </a:p>
@@ -8911,7 +8943,7 @@
                 <a:ea typeface="Calibri"/>
                 <a:cs typeface="Calibri"/>
               </a:rPr>
-              <a:t>reach, delivery per class, hops, latency. Set device counts and radio range and watch the </a:t>
+              <a:t>reach, delivery per class, hops, latency. Set device counts and radio range and see how </a:t>
             </a:r>
             <a:r>
               <a:rPr lang="en-US" sz="1400" b="1">
@@ -8922,7 +8954,7 @@
                 <a:ea typeface="Calibri"/>
                 <a:cs typeface="Calibri"/>
               </a:rPr>
-              <a:t>percolation threshold</a:t>
+              <a:t>coverage</a:t>
             </a:r>
             <a:r>
               <a:rPr lang="en-US" sz="1400">
@@ -8933,7 +8965,7 @@
                 <a:ea typeface="Calibri"/>
                 <a:cs typeface="Calibri"/>
               </a:rPr>
-              <a:t>: how few nodes are enough.</a:t>
+              <a:t> changes with fewer nodes.</a:t>
             </a:r>
             <a:endParaRPr lang="en-US" sz="1400"/>
           </a:p>
@@ -9086,7 +9118,7 @@
                 <a:ea typeface="Calibri"/>
                 <a:cs typeface="Calibri"/>
               </a:rPr>
-              <a:t>cryptography is standard and not simulated; the simulation is about mesh behaviour</a:t>
+              <a:t>cryptography (a trust flag stands in), topology gossip, rate limits, AED registry and guidance, casualty reports, router portal, Daily OK. Timers are compressed for the demo</a:t>
             </a:r>
             <a:endParaRPr lang="en-US" sz="1300"/>
           </a:p>

</xml_diff>

<commit_message>
docs: update pitch materials and add simulation screenshot
- Updated the Pomóc PDF and PPTX files to reflect recent changes.
- Added a new screenshot of the simulation to enhance visual documentation.
</commit_message>
<xml_diff>
--- a/docs/pitch/pomoc.pptx
+++ b/docs/pitch/pomoc.pptx
@@ -8066,16 +8066,45 @@
           </a:p>
         </p:txBody>
       </p:sp>
-      <p:sp>
-        <p:nvSpPr>
-          <p:cNvPr id="1437537097" name="Text 2"/>
+      <p:pic>
+        <p:nvPicPr>
+          <p:cNvPr id="900001" name="Sim screenshot" descr="Pomóc simulation on a Kraków district map during an L1 disruption"/>
+          <p:cNvPicPr>
+            <a:picLocks noChangeAspect="1"/>
+          </p:cNvPicPr>
+          <p:nvPr/>
+        </p:nvPicPr>
+        <p:blipFill>
+          <a:blip r:embed="rId3"/>
+          <a:stretch>
+            <a:fillRect/>
+          </a:stretch>
+        </p:blipFill>
+        <p:spPr>
+          <a:xfrm>
+            <a:off x="548640" y="1234440"/>
+            <a:ext cx="5262498" cy="2944368"/>
+          </a:xfrm>
+          <a:prstGeom prst="rect">
+            <a:avLst/>
+          </a:prstGeom>
+          <a:ln w="9525">
+            <a:solidFill>
+              <a:srgbClr val="D0D7DE"/>
+            </a:solidFill>
+          </a:ln>
+        </p:spPr>
+      </p:pic>
+      <p:sp>
+        <p:nvSpPr>
+          <p:cNvPr id="844598415" name="Text 27"/>
           <p:cNvSpPr txBox="1"/>
           <p:nvPr/>
         </p:nvSpPr>
         <p:spPr bwMode="auto">
           <a:xfrm>
-            <a:off x="548640" y="1234440"/>
-            <a:ext cx="6766560" cy="731520"/>
+            <a:off x="548640" y="4297680"/>
+            <a:ext cx="6766560" cy="960120"/>
           </a:xfrm>
           <a:prstGeom prst="rect">
             <a:avLst/>
@@ -8088,11 +8117,25 @@
           <a:lstStyle/>
           <a:p>
             <a:pPr marL="0" indent="0">
-              <a:buNone/>
-              <a:defRPr/>
-            </a:pPr>
-            <a:r>
-              <a:rPr lang="en-US" sz="1500">
+              <a:spcAft>
+                <a:spcPts val="600"/>
+              </a:spcAft>
+              <a:buNone/>
+              <a:defRPr/>
+            </a:pPr>
+            <a:r>
+              <a:rPr lang="en-US" sz="1200" b="1">
+                <a:solidFill>
+                  <a:srgbClr val="0E1B2C"/>
+                </a:solidFill>
+                <a:latin typeface="Calibri"/>
+                <a:ea typeface="Calibri"/>
+                <a:cs typeface="Calibri"/>
+              </a:rPr>
+              <a:t>Kraków, playable step by step: </a:t>
+            </a:r>
+            <a:r>
+              <a:rPr lang="en-US" sz="1200">
                 <a:solidFill>
                   <a:srgbClr val="1B2A3D"/>
                 </a:solidFill>
@@ -8100,874 +8143,59 @@
                 <a:ea typeface="Calibri"/>
                 <a:cs typeface="Calibri"/>
               </a:rPr>
-              <a:t>Kraków district, static router layer plus mobile phone layer, in one interactive one-pager. Deterministic, playable step by step:</a:t>
-            </a:r>
-            <a:endParaRPr lang="en-US" sz="1500"/>
-          </a:p>
-        </p:txBody>
-      </p:sp>
-      <p:sp>
-        <p:nvSpPr>
-          <p:cNvPr id="1981180555" name="Shape 3"/>
-          <p:cNvSpPr/>
-          <p:nvPr/>
-        </p:nvSpPr>
-        <p:spPr bwMode="auto">
-          <a:xfrm>
-            <a:off x="548640" y="2103120"/>
-            <a:ext cx="3200400" cy="548640"/>
-          </a:xfrm>
-          <a:prstGeom prst="roundRect">
-            <a:avLst>
-              <a:gd name="adj" fmla="val 50000"/>
-            </a:avLst>
-          </a:prstGeom>
-          <a:solidFill>
-            <a:srgbClr val="E3F5F2"/>
-          </a:solidFill>
-          <a:ln w="12700">
-            <a:solidFill>
-              <a:srgbClr val="E3F5F2"/>
-            </a:solidFill>
-            <a:prstDash val="solid"/>
-          </a:ln>
-        </p:spPr>
-      </p:sp>
-      <p:sp>
-        <p:nvSpPr>
-          <p:cNvPr id="2039807700" name="Shape 4"/>
-          <p:cNvSpPr/>
-          <p:nvPr/>
-        </p:nvSpPr>
-        <p:spPr bwMode="auto">
-          <a:xfrm>
-            <a:off x="658368" y="2194560"/>
-            <a:ext cx="365760" cy="365760"/>
-          </a:xfrm>
-          <a:prstGeom prst="ellipse">
-            <a:avLst/>
-          </a:prstGeom>
-          <a:solidFill>
-            <a:srgbClr val="12A594"/>
-          </a:solidFill>
-          <a:ln w="12700">
-            <a:solidFill>
-              <a:srgbClr val="12A594"/>
-            </a:solidFill>
-            <a:prstDash val="solid"/>
-          </a:ln>
-        </p:spPr>
-      </p:sp>
-      <p:sp>
-        <p:nvSpPr>
-          <p:cNvPr id="1451426289" name="Text 5"/>
-          <p:cNvSpPr txBox="1"/>
-          <p:nvPr/>
-        </p:nvSpPr>
-        <p:spPr bwMode="auto">
-          <a:xfrm>
-            <a:off x="658368" y="2194560"/>
-            <a:ext cx="365760" cy="365760"/>
-          </a:xfrm>
-          <a:prstGeom prst="rect">
-            <a:avLst/>
-          </a:prstGeom>
-          <a:noFill/>
-          <a:ln/>
-        </p:spPr>
-        <p:txBody>
-          <a:bodyPr wrap="square" lIns="0" tIns="0" rIns="0" bIns="0" rtlCol="0" anchor="ctr"/>
-          <a:lstStyle/>
-          <a:p>
-            <a:pPr marL="0" indent="0" algn="ctr">
+              <a:t>1 peace match  ·  2 flooding, TTL, dedup  ·  3 cells down → L1  ·  4 power down → store-and-forward  ·  5 L2 west, L3 east  ·  6 forged request rejected</a:t>
+            </a:r>
+          </a:p>
+          <a:p>
+            <a:pPr marL="0" indent="0">
               <a:buNone/>
               <a:defRPr/>
             </a:pPr>
             <a:r>
               <a:rPr lang="en-US" sz="1200" b="1">
                 <a:solidFill>
-                  <a:srgbClr val="FFFFFF"/>
-                </a:solidFill>
-                <a:latin typeface="Calibri"/>
-                <a:ea typeface="Calibri"/>
-                <a:cs typeface="Calibri"/>
-              </a:rPr>
-              <a:t>1</a:t>
+                  <a:srgbClr val="0E1B2C"/>
+                </a:solidFill>
+                <a:latin typeface="Calibri"/>
+                <a:ea typeface="Calibri"/>
+                <a:cs typeface="Calibri"/>
+              </a:rPr>
+              <a:t>Live metrics: </a:t>
+            </a:r>
+            <a:r>
+              <a:rPr lang="en-US" sz="1200">
+                <a:solidFill>
+                  <a:srgbClr val="1B2A3D"/>
+                </a:solidFill>
+                <a:latin typeface="Calibri"/>
+                <a:ea typeface="Calibri"/>
+                <a:cs typeface="Calibri"/>
+              </a:rPr>
+              <a:t>reach, delivery per class, hops, latency. Set device counts and radio range and see how </a:t>
+            </a:r>
+            <a:r>
+              <a:rPr lang="en-US" sz="1200" b="1">
+                <a:solidFill>
+                  <a:srgbClr val="0E1B2C"/>
+                </a:solidFill>
+                <a:latin typeface="Calibri"/>
+                <a:ea typeface="Calibri"/>
+                <a:cs typeface="Calibri"/>
+              </a:rPr>
+              <a:t>coverage</a:t>
+            </a:r>
+            <a:r>
+              <a:rPr lang="en-US" sz="1200">
+                <a:solidFill>
+                  <a:srgbClr val="1B2A3D"/>
+                </a:solidFill>
+                <a:latin typeface="Calibri"/>
+                <a:ea typeface="Calibri"/>
+                <a:cs typeface="Calibri"/>
+              </a:rPr>
+              <a:t> changes with fewer nodes.</a:t>
             </a:r>
             <a:endParaRPr lang="en-US" sz="1200"/>
-          </a:p>
-        </p:txBody>
-      </p:sp>
-      <p:sp>
-        <p:nvSpPr>
-          <p:cNvPr id="1161876405" name="Text 6"/>
-          <p:cNvSpPr txBox="1"/>
-          <p:nvPr/>
-        </p:nvSpPr>
-        <p:spPr bwMode="auto">
-          <a:xfrm>
-            <a:off x="1143000" y="2103120"/>
-            <a:ext cx="2560320" cy="548640"/>
-          </a:xfrm>
-          <a:prstGeom prst="rect">
-            <a:avLst/>
-          </a:prstGeom>
-          <a:noFill/>
-          <a:ln/>
-        </p:spPr>
-        <p:txBody>
-          <a:bodyPr wrap="square" lIns="0" tIns="0" rIns="0" bIns="0" rtlCol="0" anchor="ctr"/>
-          <a:lstStyle/>
-          <a:p>
-            <a:pPr marL="0" indent="0">
-              <a:buNone/>
-              <a:defRPr/>
-            </a:pPr>
-            <a:r>
-              <a:rPr lang="en-US" sz="1300" b="1">
-                <a:solidFill>
-                  <a:srgbClr val="0E1B2C"/>
-                </a:solidFill>
-                <a:latin typeface="Calibri"/>
-                <a:ea typeface="Calibri"/>
-                <a:cs typeface="Calibri"/>
-              </a:rPr>
-              <a:t>Peace request + match</a:t>
-            </a:r>
-            <a:endParaRPr lang="en-US" sz="1300"/>
-          </a:p>
-        </p:txBody>
-      </p:sp>
-      <p:sp>
-        <p:nvSpPr>
-          <p:cNvPr id="412250144" name="Shape 7"/>
-          <p:cNvSpPr/>
-          <p:nvPr/>
-        </p:nvSpPr>
-        <p:spPr bwMode="auto">
-          <a:xfrm>
-            <a:off x="3931920" y="2103120"/>
-            <a:ext cx="3200400" cy="548640"/>
-          </a:xfrm>
-          <a:prstGeom prst="roundRect">
-            <a:avLst>
-              <a:gd name="adj" fmla="val 50000"/>
-            </a:avLst>
-          </a:prstGeom>
-          <a:solidFill>
-            <a:srgbClr val="E3F5F2"/>
-          </a:solidFill>
-          <a:ln w="12700">
-            <a:solidFill>
-              <a:srgbClr val="E3F5F2"/>
-            </a:solidFill>
-            <a:prstDash val="solid"/>
-          </a:ln>
-        </p:spPr>
-      </p:sp>
-      <p:sp>
-        <p:nvSpPr>
-          <p:cNvPr id="110512087" name="Shape 8"/>
-          <p:cNvSpPr/>
-          <p:nvPr/>
-        </p:nvSpPr>
-        <p:spPr bwMode="auto">
-          <a:xfrm>
-            <a:off x="4041648" y="2194560"/>
-            <a:ext cx="365760" cy="365760"/>
-          </a:xfrm>
-          <a:prstGeom prst="ellipse">
-            <a:avLst/>
-          </a:prstGeom>
-          <a:solidFill>
-            <a:srgbClr val="12A594"/>
-          </a:solidFill>
-          <a:ln w="12700">
-            <a:solidFill>
-              <a:srgbClr val="12A594"/>
-            </a:solidFill>
-            <a:prstDash val="solid"/>
-          </a:ln>
-        </p:spPr>
-      </p:sp>
-      <p:sp>
-        <p:nvSpPr>
-          <p:cNvPr id="1175164111" name="Text 9"/>
-          <p:cNvSpPr txBox="1"/>
-          <p:nvPr/>
-        </p:nvSpPr>
-        <p:spPr bwMode="auto">
-          <a:xfrm>
-            <a:off x="4041648" y="2194560"/>
-            <a:ext cx="365760" cy="365760"/>
-          </a:xfrm>
-          <a:prstGeom prst="rect">
-            <a:avLst/>
-          </a:prstGeom>
-          <a:noFill/>
-          <a:ln/>
-        </p:spPr>
-        <p:txBody>
-          <a:bodyPr wrap="square" lIns="0" tIns="0" rIns="0" bIns="0" rtlCol="0" anchor="ctr"/>
-          <a:lstStyle/>
-          <a:p>
-            <a:pPr marL="0" indent="0" algn="ctr">
-              <a:buNone/>
-              <a:defRPr/>
-            </a:pPr>
-            <a:r>
-              <a:rPr lang="en-US" sz="1200" b="1">
-                <a:solidFill>
-                  <a:srgbClr val="FFFFFF"/>
-                </a:solidFill>
-                <a:latin typeface="Calibri"/>
-                <a:ea typeface="Calibri"/>
-                <a:cs typeface="Calibri"/>
-              </a:rPr>
-              <a:t>2</a:t>
-            </a:r>
-            <a:endParaRPr lang="en-US" sz="1200"/>
-          </a:p>
-        </p:txBody>
-      </p:sp>
-      <p:sp>
-        <p:nvSpPr>
-          <p:cNvPr id="187483474" name="Text 10"/>
-          <p:cNvSpPr txBox="1"/>
-          <p:nvPr/>
-        </p:nvSpPr>
-        <p:spPr bwMode="auto">
-          <a:xfrm>
-            <a:off x="4526280" y="2103120"/>
-            <a:ext cx="2560320" cy="548640"/>
-          </a:xfrm>
-          <a:prstGeom prst="rect">
-            <a:avLst/>
-          </a:prstGeom>
-          <a:noFill/>
-          <a:ln/>
-        </p:spPr>
-        <p:txBody>
-          <a:bodyPr wrap="square" lIns="0" tIns="0" rIns="0" bIns="0" rtlCol="0" anchor="ctr"/>
-          <a:lstStyle/>
-          <a:p>
-            <a:pPr marL="0" indent="0">
-              <a:buNone/>
-              <a:defRPr/>
-            </a:pPr>
-            <a:r>
-              <a:rPr lang="en-US" sz="1300" b="1">
-                <a:solidFill>
-                  <a:srgbClr val="0E1B2C"/>
-                </a:solidFill>
-                <a:latin typeface="Calibri"/>
-                <a:ea typeface="Calibri"/>
-                <a:cs typeface="Calibri"/>
-              </a:rPr>
-              <a:t>Flooding: hop limit, TTL, dedup</a:t>
-            </a:r>
-            <a:endParaRPr lang="en-US" sz="1300"/>
-          </a:p>
-        </p:txBody>
-      </p:sp>
-      <p:sp>
-        <p:nvSpPr>
-          <p:cNvPr id="1935030632" name="Shape 11"/>
-          <p:cNvSpPr/>
-          <p:nvPr/>
-        </p:nvSpPr>
-        <p:spPr bwMode="auto">
-          <a:xfrm>
-            <a:off x="548640" y="2788920"/>
-            <a:ext cx="3200400" cy="548640"/>
-          </a:xfrm>
-          <a:prstGeom prst="roundRect">
-            <a:avLst>
-              <a:gd name="adj" fmla="val 50000"/>
-            </a:avLst>
-          </a:prstGeom>
-          <a:solidFill>
-            <a:srgbClr val="E3F5F2"/>
-          </a:solidFill>
-          <a:ln w="12700">
-            <a:solidFill>
-              <a:srgbClr val="E3F5F2"/>
-            </a:solidFill>
-            <a:prstDash val="solid"/>
-          </a:ln>
-        </p:spPr>
-      </p:sp>
-      <p:sp>
-        <p:nvSpPr>
-          <p:cNvPr id="482885579" name="Shape 12"/>
-          <p:cNvSpPr/>
-          <p:nvPr/>
-        </p:nvSpPr>
-        <p:spPr bwMode="auto">
-          <a:xfrm>
-            <a:off x="658368" y="2880360"/>
-            <a:ext cx="365760" cy="365760"/>
-          </a:xfrm>
-          <a:prstGeom prst="ellipse">
-            <a:avLst/>
-          </a:prstGeom>
-          <a:solidFill>
-            <a:srgbClr val="12A594"/>
-          </a:solidFill>
-          <a:ln w="12700">
-            <a:solidFill>
-              <a:srgbClr val="12A594"/>
-            </a:solidFill>
-            <a:prstDash val="solid"/>
-          </a:ln>
-        </p:spPr>
-      </p:sp>
-      <p:sp>
-        <p:nvSpPr>
-          <p:cNvPr id="94839128" name="Text 13"/>
-          <p:cNvSpPr txBox="1"/>
-          <p:nvPr/>
-        </p:nvSpPr>
-        <p:spPr bwMode="auto">
-          <a:xfrm>
-            <a:off x="658368" y="2880360"/>
-            <a:ext cx="365760" cy="365760"/>
-          </a:xfrm>
-          <a:prstGeom prst="rect">
-            <a:avLst/>
-          </a:prstGeom>
-          <a:noFill/>
-          <a:ln/>
-        </p:spPr>
-        <p:txBody>
-          <a:bodyPr wrap="square" lIns="0" tIns="0" rIns="0" bIns="0" rtlCol="0" anchor="ctr"/>
-          <a:lstStyle/>
-          <a:p>
-            <a:pPr marL="0" indent="0" algn="ctr">
-              <a:buNone/>
-              <a:defRPr/>
-            </a:pPr>
-            <a:r>
-              <a:rPr lang="en-US" sz="1200" b="1">
-                <a:solidFill>
-                  <a:srgbClr val="FFFFFF"/>
-                </a:solidFill>
-                <a:latin typeface="Calibri"/>
-                <a:ea typeface="Calibri"/>
-                <a:cs typeface="Calibri"/>
-              </a:rPr>
-              <a:t>3</a:t>
-            </a:r>
-            <a:endParaRPr lang="en-US" sz="1200"/>
-          </a:p>
-        </p:txBody>
-      </p:sp>
-      <p:sp>
-        <p:nvSpPr>
-          <p:cNvPr id="905114869" name="Text 14"/>
-          <p:cNvSpPr txBox="1"/>
-          <p:nvPr/>
-        </p:nvSpPr>
-        <p:spPr bwMode="auto">
-          <a:xfrm>
-            <a:off x="1143000" y="2788920"/>
-            <a:ext cx="2560320" cy="548640"/>
-          </a:xfrm>
-          <a:prstGeom prst="rect">
-            <a:avLst/>
-          </a:prstGeom>
-          <a:noFill/>
-          <a:ln/>
-        </p:spPr>
-        <p:txBody>
-          <a:bodyPr wrap="square" lIns="0" tIns="0" rIns="0" bIns="0" rtlCol="0" anchor="ctr"/>
-          <a:lstStyle/>
-          <a:p>
-            <a:pPr marL="0" indent="0">
-              <a:buNone/>
-              <a:defRPr/>
-            </a:pPr>
-            <a:r>
-              <a:rPr lang="en-US" sz="1300" b="1">
-                <a:solidFill>
-                  <a:srgbClr val="0E1B2C"/>
-                </a:solidFill>
-                <a:latin typeface="Calibri"/>
-                <a:ea typeface="Calibri"/>
-                <a:cs typeface="Calibri"/>
-              </a:rPr>
-              <a:t>Cells down → L1, router backbone</a:t>
-            </a:r>
-            <a:endParaRPr lang="en-US" sz="1300"/>
-          </a:p>
-        </p:txBody>
-      </p:sp>
-      <p:sp>
-        <p:nvSpPr>
-          <p:cNvPr id="1130715960" name="Shape 15"/>
-          <p:cNvSpPr/>
-          <p:nvPr/>
-        </p:nvSpPr>
-        <p:spPr bwMode="auto">
-          <a:xfrm>
-            <a:off x="3931920" y="2788920"/>
-            <a:ext cx="3200400" cy="548640"/>
-          </a:xfrm>
-          <a:prstGeom prst="roundRect">
-            <a:avLst>
-              <a:gd name="adj" fmla="val 50000"/>
-            </a:avLst>
-          </a:prstGeom>
-          <a:solidFill>
-            <a:srgbClr val="E3F5F2"/>
-          </a:solidFill>
-          <a:ln w="12700">
-            <a:solidFill>
-              <a:srgbClr val="E3F5F2"/>
-            </a:solidFill>
-            <a:prstDash val="solid"/>
-          </a:ln>
-        </p:spPr>
-      </p:sp>
-      <p:sp>
-        <p:nvSpPr>
-          <p:cNvPr id="1971227610" name="Shape 16"/>
-          <p:cNvSpPr/>
-          <p:nvPr/>
-        </p:nvSpPr>
-        <p:spPr bwMode="auto">
-          <a:xfrm>
-            <a:off x="4041648" y="2880360"/>
-            <a:ext cx="365760" cy="365760"/>
-          </a:xfrm>
-          <a:prstGeom prst="ellipse">
-            <a:avLst/>
-          </a:prstGeom>
-          <a:solidFill>
-            <a:srgbClr val="12A594"/>
-          </a:solidFill>
-          <a:ln w="12700">
-            <a:solidFill>
-              <a:srgbClr val="12A594"/>
-            </a:solidFill>
-            <a:prstDash val="solid"/>
-          </a:ln>
-        </p:spPr>
-      </p:sp>
-      <p:sp>
-        <p:nvSpPr>
-          <p:cNvPr id="790109138" name="Text 17"/>
-          <p:cNvSpPr txBox="1"/>
-          <p:nvPr/>
-        </p:nvSpPr>
-        <p:spPr bwMode="auto">
-          <a:xfrm>
-            <a:off x="4041648" y="2880360"/>
-            <a:ext cx="365760" cy="365760"/>
-          </a:xfrm>
-          <a:prstGeom prst="rect">
-            <a:avLst/>
-          </a:prstGeom>
-          <a:noFill/>
-          <a:ln/>
-        </p:spPr>
-        <p:txBody>
-          <a:bodyPr wrap="square" lIns="0" tIns="0" rIns="0" bIns="0" rtlCol="0" anchor="ctr"/>
-          <a:lstStyle/>
-          <a:p>
-            <a:pPr marL="0" indent="0" algn="ctr">
-              <a:buNone/>
-              <a:defRPr/>
-            </a:pPr>
-            <a:r>
-              <a:rPr lang="en-US" sz="1200" b="1">
-                <a:solidFill>
-                  <a:srgbClr val="FFFFFF"/>
-                </a:solidFill>
-                <a:latin typeface="Calibri"/>
-                <a:ea typeface="Calibri"/>
-                <a:cs typeface="Calibri"/>
-              </a:rPr>
-              <a:t>4</a:t>
-            </a:r>
-            <a:endParaRPr lang="en-US" sz="1200"/>
-          </a:p>
-        </p:txBody>
-      </p:sp>
-      <p:sp>
-        <p:nvSpPr>
-          <p:cNvPr id="1902808971" name="Text 18"/>
-          <p:cNvSpPr txBox="1"/>
-          <p:nvPr/>
-        </p:nvSpPr>
-        <p:spPr bwMode="auto">
-          <a:xfrm>
-            <a:off x="4526280" y="2788920"/>
-            <a:ext cx="2560320" cy="548640"/>
-          </a:xfrm>
-          <a:prstGeom prst="rect">
-            <a:avLst/>
-          </a:prstGeom>
-          <a:noFill/>
-          <a:ln/>
-        </p:spPr>
-        <p:txBody>
-          <a:bodyPr wrap="square" lIns="0" tIns="0" rIns="0" bIns="0" rtlCol="0" anchor="ctr"/>
-          <a:lstStyle/>
-          <a:p>
-            <a:pPr marL="0" indent="0">
-              <a:buNone/>
-              <a:defRPr/>
-            </a:pPr>
-            <a:r>
-              <a:rPr lang="en-US" sz="1300" b="1">
-                <a:solidFill>
-                  <a:srgbClr val="0E1B2C"/>
-                </a:solidFill>
-                <a:latin typeface="Calibri"/>
-                <a:ea typeface="Calibri"/>
-                <a:cs typeface="Calibri"/>
-              </a:rPr>
-              <a:t>Power down → phone-only, store-and-forward</a:t>
-            </a:r>
-            <a:endParaRPr lang="en-US" sz="1300"/>
-          </a:p>
-        </p:txBody>
-      </p:sp>
-      <p:sp>
-        <p:nvSpPr>
-          <p:cNvPr id="1646713728" name="Shape 19"/>
-          <p:cNvSpPr/>
-          <p:nvPr/>
-        </p:nvSpPr>
-        <p:spPr bwMode="auto">
-          <a:xfrm>
-            <a:off x="548640" y="3474720"/>
-            <a:ext cx="3200400" cy="548640"/>
-          </a:xfrm>
-          <a:prstGeom prst="roundRect">
-            <a:avLst>
-              <a:gd name="adj" fmla="val 50000"/>
-            </a:avLst>
-          </a:prstGeom>
-          <a:solidFill>
-            <a:srgbClr val="E3F5F2"/>
-          </a:solidFill>
-          <a:ln w="12700">
-            <a:solidFill>
-              <a:srgbClr val="E3F5F2"/>
-            </a:solidFill>
-            <a:prstDash val="solid"/>
-          </a:ln>
-        </p:spPr>
-      </p:sp>
-      <p:sp>
-        <p:nvSpPr>
-          <p:cNvPr id="456264795" name="Shape 20"/>
-          <p:cNvSpPr/>
-          <p:nvPr/>
-        </p:nvSpPr>
-        <p:spPr bwMode="auto">
-          <a:xfrm>
-            <a:off x="658368" y="3566160"/>
-            <a:ext cx="365760" cy="365760"/>
-          </a:xfrm>
-          <a:prstGeom prst="ellipse">
-            <a:avLst/>
-          </a:prstGeom>
-          <a:solidFill>
-            <a:srgbClr val="12A594"/>
-          </a:solidFill>
-          <a:ln w="12700">
-            <a:solidFill>
-              <a:srgbClr val="12A594"/>
-            </a:solidFill>
-            <a:prstDash val="solid"/>
-          </a:ln>
-        </p:spPr>
-      </p:sp>
-      <p:sp>
-        <p:nvSpPr>
-          <p:cNvPr id="885077313" name="Text 21"/>
-          <p:cNvSpPr txBox="1"/>
-          <p:nvPr/>
-        </p:nvSpPr>
-        <p:spPr bwMode="auto">
-          <a:xfrm>
-            <a:off x="658368" y="3566160"/>
-            <a:ext cx="365760" cy="365760"/>
-          </a:xfrm>
-          <a:prstGeom prst="rect">
-            <a:avLst/>
-          </a:prstGeom>
-          <a:noFill/>
-          <a:ln/>
-        </p:spPr>
-        <p:txBody>
-          <a:bodyPr wrap="square" lIns="0" tIns="0" rIns="0" bIns="0" rtlCol="0" anchor="ctr"/>
-          <a:lstStyle/>
-          <a:p>
-            <a:pPr marL="0" indent="0" algn="ctr">
-              <a:buNone/>
-              <a:defRPr/>
-            </a:pPr>
-            <a:r>
-              <a:rPr lang="en-US" sz="1200" b="1">
-                <a:solidFill>
-                  <a:srgbClr val="FFFFFF"/>
-                </a:solidFill>
-                <a:latin typeface="Calibri"/>
-                <a:ea typeface="Calibri"/>
-                <a:cs typeface="Calibri"/>
-              </a:rPr>
-              <a:t>5</a:t>
-            </a:r>
-            <a:endParaRPr lang="en-US" sz="1200"/>
-          </a:p>
-        </p:txBody>
-      </p:sp>
-      <p:sp>
-        <p:nvSpPr>
-          <p:cNvPr id="1489836331" name="Text 22"/>
-          <p:cNvSpPr txBox="1"/>
-          <p:nvPr/>
-        </p:nvSpPr>
-        <p:spPr bwMode="auto">
-          <a:xfrm>
-            <a:off x="1143000" y="3474720"/>
-            <a:ext cx="2560320" cy="548640"/>
-          </a:xfrm>
-          <a:prstGeom prst="rect">
-            <a:avLst/>
-          </a:prstGeom>
-          <a:noFill/>
-          <a:ln/>
-        </p:spPr>
-        <p:txBody>
-          <a:bodyPr wrap="square" lIns="0" tIns="0" rIns="0" bIns="0" rtlCol="0" anchor="ctr"/>
-          <a:lstStyle/>
-          <a:p>
-            <a:pPr marL="0" indent="0">
-              <a:buNone/>
-              <a:defRPr/>
-            </a:pPr>
-            <a:r>
-              <a:rPr lang="en-US" sz="1300" b="1">
-                <a:solidFill>
-                  <a:srgbClr val="0E1B2C"/>
-                </a:solidFill>
-                <a:latin typeface="Calibri"/>
-                <a:ea typeface="Calibri"/>
-                <a:cs typeface="Calibri"/>
-              </a:rPr>
-              <a:t>L2 west, L3 east: regional declarations</a:t>
-            </a:r>
-            <a:endParaRPr lang="en-US" sz="1300"/>
-          </a:p>
-        </p:txBody>
-      </p:sp>
-      <p:sp>
-        <p:nvSpPr>
-          <p:cNvPr id="1952981667" name="Shape 23"/>
-          <p:cNvSpPr/>
-          <p:nvPr/>
-        </p:nvSpPr>
-        <p:spPr bwMode="auto">
-          <a:xfrm>
-            <a:off x="3931920" y="3474720"/>
-            <a:ext cx="3200400" cy="548640"/>
-          </a:xfrm>
-          <a:prstGeom prst="roundRect">
-            <a:avLst>
-              <a:gd name="adj" fmla="val 50000"/>
-            </a:avLst>
-          </a:prstGeom>
-          <a:solidFill>
-            <a:srgbClr val="E3F5F2"/>
-          </a:solidFill>
-          <a:ln w="12700">
-            <a:solidFill>
-              <a:srgbClr val="E3F5F2"/>
-            </a:solidFill>
-            <a:prstDash val="solid"/>
-          </a:ln>
-        </p:spPr>
-      </p:sp>
-      <p:sp>
-        <p:nvSpPr>
-          <p:cNvPr id="1309794040" name="Shape 24"/>
-          <p:cNvSpPr/>
-          <p:nvPr/>
-        </p:nvSpPr>
-        <p:spPr bwMode="auto">
-          <a:xfrm>
-            <a:off x="4041648" y="3566160"/>
-            <a:ext cx="365760" cy="365760"/>
-          </a:xfrm>
-          <a:prstGeom prst="ellipse">
-            <a:avLst/>
-          </a:prstGeom>
-          <a:solidFill>
-            <a:srgbClr val="12A594"/>
-          </a:solidFill>
-          <a:ln w="12700">
-            <a:solidFill>
-              <a:srgbClr val="12A594"/>
-            </a:solidFill>
-            <a:prstDash val="solid"/>
-          </a:ln>
-        </p:spPr>
-      </p:sp>
-      <p:sp>
-        <p:nvSpPr>
-          <p:cNvPr id="349084974" name="Text 25"/>
-          <p:cNvSpPr txBox="1"/>
-          <p:nvPr/>
-        </p:nvSpPr>
-        <p:spPr bwMode="auto">
-          <a:xfrm>
-            <a:off x="4041648" y="3566160"/>
-            <a:ext cx="365760" cy="365760"/>
-          </a:xfrm>
-          <a:prstGeom prst="rect">
-            <a:avLst/>
-          </a:prstGeom>
-          <a:noFill/>
-          <a:ln/>
-        </p:spPr>
-        <p:txBody>
-          <a:bodyPr wrap="square" lIns="0" tIns="0" rIns="0" bIns="0" rtlCol="0" anchor="ctr"/>
-          <a:lstStyle/>
-          <a:p>
-            <a:pPr marL="0" indent="0" algn="ctr">
-              <a:buNone/>
-              <a:defRPr/>
-            </a:pPr>
-            <a:r>
-              <a:rPr lang="en-US" sz="1200" b="1">
-                <a:solidFill>
-                  <a:srgbClr val="FFFFFF"/>
-                </a:solidFill>
-                <a:latin typeface="Calibri"/>
-                <a:ea typeface="Calibri"/>
-                <a:cs typeface="Calibri"/>
-              </a:rPr>
-              <a:t>6</a:t>
-            </a:r>
-            <a:endParaRPr lang="en-US" sz="1200"/>
-          </a:p>
-        </p:txBody>
-      </p:sp>
-      <p:sp>
-        <p:nvSpPr>
-          <p:cNvPr id="1781359038" name="Text 26"/>
-          <p:cNvSpPr txBox="1"/>
-          <p:nvPr/>
-        </p:nvSpPr>
-        <p:spPr bwMode="auto">
-          <a:xfrm>
-            <a:off x="4526280" y="3474720"/>
-            <a:ext cx="2560320" cy="548640"/>
-          </a:xfrm>
-          <a:prstGeom prst="rect">
-            <a:avLst/>
-          </a:prstGeom>
-          <a:noFill/>
-          <a:ln/>
-        </p:spPr>
-        <p:txBody>
-          <a:bodyPr wrap="square" lIns="0" tIns="0" rIns="0" bIns="0" rtlCol="0" anchor="ctr"/>
-          <a:lstStyle/>
-          <a:p>
-            <a:pPr marL="0" indent="0">
-              <a:buNone/>
-              <a:defRPr/>
-            </a:pPr>
-            <a:r>
-              <a:rPr lang="en-US" sz="1300" b="1">
-                <a:solidFill>
-                  <a:srgbClr val="0E1B2C"/>
-                </a:solidFill>
-                <a:latin typeface="Calibri"/>
-                <a:ea typeface="Calibri"/>
-                <a:cs typeface="Calibri"/>
-              </a:rPr>
-              <a:t>Forged request rejected</a:t>
-            </a:r>
-            <a:endParaRPr lang="en-US" sz="1300"/>
-          </a:p>
-        </p:txBody>
-      </p:sp>
-      <p:sp>
-        <p:nvSpPr>
-          <p:cNvPr id="844598415" name="Text 27"/>
-          <p:cNvSpPr txBox="1"/>
-          <p:nvPr/>
-        </p:nvSpPr>
-        <p:spPr bwMode="auto">
-          <a:xfrm>
-            <a:off x="548640" y="4251960"/>
-            <a:ext cx="6766560" cy="822960"/>
-          </a:xfrm>
-          <a:prstGeom prst="rect">
-            <a:avLst/>
-          </a:prstGeom>
-          <a:noFill/>
-          <a:ln/>
-        </p:spPr>
-        <p:txBody>
-          <a:bodyPr wrap="square" lIns="0" tIns="0" rIns="0" bIns="0" rtlCol="0" anchor="t"/>
-          <a:lstStyle/>
-          <a:p>
-            <a:pPr marL="0" indent="0">
-              <a:buNone/>
-              <a:defRPr/>
-            </a:pPr>
-            <a:r>
-              <a:rPr lang="en-US" sz="1400" b="1">
-                <a:solidFill>
-                  <a:srgbClr val="0E1B2C"/>
-                </a:solidFill>
-                <a:latin typeface="Calibri"/>
-                <a:ea typeface="Calibri"/>
-                <a:cs typeface="Calibri"/>
-              </a:rPr>
-              <a:t>Live metrics: </a:t>
-            </a:r>
-            <a:r>
-              <a:rPr lang="en-US" sz="1400">
-                <a:solidFill>
-                  <a:srgbClr val="1B2A3D"/>
-                </a:solidFill>
-                <a:latin typeface="Calibri"/>
-                <a:ea typeface="Calibri"/>
-                <a:cs typeface="Calibri"/>
-              </a:rPr>
-              <a:t>reach, delivery per class, hops, latency. Set device counts and radio range and see how </a:t>
-            </a:r>
-            <a:r>
-              <a:rPr lang="en-US" sz="1400" b="1">
-                <a:solidFill>
-                  <a:srgbClr val="0E1B2C"/>
-                </a:solidFill>
-                <a:latin typeface="Calibri"/>
-                <a:ea typeface="Calibri"/>
-                <a:cs typeface="Calibri"/>
-              </a:rPr>
-              <a:t>coverage</a:t>
-            </a:r>
-            <a:r>
-              <a:rPr lang="en-US" sz="1400">
-                <a:solidFill>
-                  <a:srgbClr val="1B2A3D"/>
-                </a:solidFill>
-                <a:latin typeface="Calibri"/>
-                <a:ea typeface="Calibri"/>
-                <a:cs typeface="Calibri"/>
-              </a:rPr>
-              <a:t> changes with fewer nodes.</a:t>
-            </a:r>
-            <a:endParaRPr lang="en-US" sz="1400"/>
           </a:p>
         </p:txBody>
       </p:sp>

</xml_diff>